<commit_message>
M21: Sim-Review umgesetzt (sim_review true, Inhalt aktualisiert)
Co-Authored-By: Claude Opus 4.8 <noreply@anthropic.com>
</commit_message>
<xml_diff>
--- a/protected-downloads/praesentation/M21.pptx
+++ b/protected-downloads/praesentation/M21.pptx
@@ -12993,7 +12993,7 @@
                 </a:solidFill>
                 <a:latin typeface="Consolas"/>
               </a:rPr>
-              <a:t>09:00–09:25 </a:t>
+              <a:t>09:00–09:30 </a:t>
             </a:r>
             <a:r>
               <a:rPr sz="1200" b="1">
@@ -13030,7 +13030,7 @@
                 </a:solidFill>
                 <a:latin typeface="Consolas"/>
               </a:rPr>
-              <a:t>09:25–09:30 </a:t>
+              <a:t>09:30–09:35 </a:t>
             </a:r>
             <a:r>
               <a:rPr sz="1200" b="1">
@@ -13067,7 +13067,7 @@
                 </a:solidFill>
                 <a:latin typeface="Consolas"/>
               </a:rPr>
-              <a:t>09:30–10:15 </a:t>
+              <a:t>09:35–10:20 </a:t>
             </a:r>
             <a:r>
               <a:rPr sz="1200" b="1">
@@ -13104,7 +13104,7 @@
                 </a:solidFill>
                 <a:latin typeface="Consolas"/>
               </a:rPr>
-              <a:t>10:15–10:25 </a:t>
+              <a:t>10:20–10:30 </a:t>
             </a:r>
             <a:r>
               <a:rPr sz="1200" b="1">
@@ -13141,7 +13141,7 @@
                 </a:solidFill>
                 <a:latin typeface="Consolas"/>
               </a:rPr>
-              <a:t>10:25–10:55 </a:t>
+              <a:t>10:30–11:00 </a:t>
             </a:r>
             <a:r>
               <a:rPr sz="1200" b="1">
@@ -13178,7 +13178,7 @@
                 </a:solidFill>
                 <a:latin typeface="Consolas"/>
               </a:rPr>
-              <a:t>10:55–11:25 </a:t>
+              <a:t>11:00–11:30 </a:t>
             </a:r>
             <a:r>
               <a:rPr sz="1200" b="1">
@@ -13215,7 +13215,7 @@
                 </a:solidFill>
                 <a:latin typeface="Consolas"/>
               </a:rPr>
-              <a:t>11:25–11:45 </a:t>
+              <a:t>11:30–11:50 </a:t>
             </a:r>
             <a:r>
               <a:rPr sz="1200" b="1">
@@ -13252,7 +13252,7 @@
                 </a:solidFill>
                 <a:latin typeface="Consolas"/>
               </a:rPr>
-              <a:t>11:45–11:55 </a:t>
+              <a:t>11:50–12:00 </a:t>
             </a:r>
             <a:r>
               <a:rPr sz="1200" b="1">
@@ -13289,7 +13289,7 @@
                 </a:solidFill>
                 <a:latin typeface="Consolas"/>
               </a:rPr>
-              <a:t>11:55–12:00 </a:t>
+              <a:t>12:00–12:05 </a:t>
             </a:r>
             <a:r>
               <a:rPr sz="1200" b="1">

</xml_diff>